<commit_message>
fix(m3): bump container sleepAfter to 1h, polish cartel, add M3 PDF supplement
- deployment/src/index.ts: sleepAfter "5m" → "1h" para reducir
  arranques en frío durante la demo de evaluación.
- scripts/generate_pdf_m3.py: arregla ruta de salida (estaba escribiendo
  fuera del repo). Añade nota sobre account_id y arranque en frío.
- Suplemento_M3_*.pdf: ahora dentro del repo (~6 MB, 6 páginas).
- scripts/generate_cartel.py: texto más conciso por sección para
  reducir traslapes con figuras; mismas 8 secciones, mismas 5 figuras.
- Cartel pptx/pdf regenerados.

Co-Authored-By: Claude Opus 4.7 (1M context) <noreply@anthropic.com>
</commit_message>
<xml_diff>
--- a/Cartel_ProyectoFinal_EduardoGarcia_FernandoRamos.pptx
+++ b/Cartel_ProyectoFinal_EduardoGarcia_FernandoRamos.pptx
@@ -4668,7 +4668,7 @@
                   <a:srgbClr val="1A1A1A"/>
                 </a:solidFill>
               </a:rPr>
-              <a:t>El experimento confirma que un pipeline MLOps disciplinado (DVC + MLflow + registro por alias + verificación de paridad) permite mover un modelo desde un notebook hasta un endpoint público sin perder reproducibilidad ni precisión.</a:t>
+              <a:t>Un pipeline MLOps disciplinado (DVC + MLflow + registro por alias + verificación de paridad) lleva un modelo desde notebook hasta endpoint público sin perder reproducibilidad ni precisión.</a:t>
             </a:r>
           </a:p>
           <a:p>
@@ -4688,7 +4688,7 @@
                   <a:srgbClr val="1A1A1A"/>
                 </a:solidFill>
               </a:rPr>
-              <a:t>El pivote de AWS a Cloudflare fue forzado pero instructivo: ONNX como formato portátil aisla el entrenamiento de la plataforma de inferencia, y los contenedores en el edge (open beta de Cloudflare) ofrecen una alternativa creíble a SageMaker para clases académicas y prototipos.</a:t>
+              <a:t>ONNX desacopla el entrenamiento de la plataforma de inferencia; los Containers de Cloudflare son alternativa creíble a SageMaker para prototipos académicos.</a:t>
             </a:r>
           </a:p>
           <a:p>
@@ -4708,17 +4708,7 @@
                   <a:srgbClr val="1A1A1A"/>
                 </a:solidFill>
               </a:rPr>
-              <a:t>Repositorio: github.com/LaloLalo1999/mlops (PR #1).</a:t>
-            </a:r>
-          </a:p>
-          <a:p>
-            <a:r>
-              <a:rPr sz="1800" b="0">
-                <a:solidFill>
-                  <a:srgbClr val="1A1A1A"/>
-                </a:solidFill>
-              </a:rPr>
-              <a:t>Endpoint en vivo: fraud-detector.eduardo-lalo1999.workers.dev</a:t>
+              <a:t>Repo: github.com/LaloLalo1999/mlops · Endpoint: fraud-detector.eduardo-lalo1999.workers.dev</a:t>
             </a:r>
           </a:p>
         </p:txBody>
@@ -4931,7 +4921,7 @@
                   <a:srgbClr val="1A1A1A"/>
                 </a:solidFill>
               </a:rPr>
-              <a:t>Construimos el pipeline en cinco etapas reproducibles, orquestadas por DVC (dvc.yaml + params.yaml) sobre un entorno Python 3.11 fijado por requirements.txt:</a:t>
+              <a:t>Pipeline en cinco etapas, orquestado por DVC sobre Python 3.11:</a:t>
             </a:r>
           </a:p>
           <a:p>
@@ -4951,7 +4941,7 @@
                   <a:srgbClr val="1A1A1A"/>
                 </a:solidFill>
               </a:rPr>
-              <a:t>1. Ingesta y preprocesamiento de OpenML 1597, escalado y partición estratificada 80/20.</a:t>
+              <a:t>1. Ingesta + preprocesamiento (OpenML 1597, partición estratificada 80/20).</a:t>
             </a:r>
           </a:p>
           <a:p>
@@ -4961,7 +4951,7 @@
                   <a:srgbClr val="1A1A1A"/>
                 </a:solidFill>
               </a:rPr>
-              <a:t>2. Entrenamiento de 7 corridas con tres familias de modelo (LogReg baseline, LightGBM y XGBoost) variando hiperparámetros y técnicas de balanceo (is_unbalance, scale_pos_weight).</a:t>
+              <a:t>2. Entrenamiento de 7 corridas (LogReg baseline, LightGBM, XGBoost) variando hiperparámetros y técnicas de balanceo.</a:t>
             </a:r>
           </a:p>
           <a:p>
@@ -4971,7 +4961,7 @@
                   <a:srgbClr val="1A1A1A"/>
                 </a:solidFill>
               </a:rPr>
-              <a:t>3. Registro en MLflow (sqlite:///mlflow.db) — métricas, parámetros, artefactos por corrida y registro del mejor modelo bajo el alias fraud-detector@staging.</a:t>
+              <a:t>3. Registro en MLflow — métricas, artefactos, y alias fraud-detector@staging sobre el mejor modelo.</a:t>
             </a:r>
           </a:p>
           <a:p>
@@ -4981,7 +4971,7 @@
                   <a:srgbClr val="1A1A1A"/>
                 </a:solidFill>
               </a:rPr>
-              <a:t>4. Sincronización de artefactos a Cloudflare R2 (bucket luci-mlops-fraud, 75 objetos, ~167 MB) usando la API de gestión REST, dado que el token cfat_ no firma SigV4.</a:t>
+              <a:t>4. Sincronización a Cloudflare R2 (bucket luci-mlops-fraud, 75 objetos, ~167 MB) vía la API de gestión REST.</a:t>
             </a:r>
           </a:p>
           <a:p>
@@ -4991,7 +4981,7 @@
                   <a:srgbClr val="1A1A1A"/>
                 </a:solidFill>
               </a:rPr>
-              <a:t>5. Despliegue: exportación a ONNX (opset 15, zipmap=False, paridad verificada a 1e-4 contra sklearn), empaquetado en contenedor Docker (python:3.11-slim + FastAPI + onnxruntime), publicación en el registro de Cloudflare y exposición vía Worker + Durable Object.</a:t>
+              <a:t>5. Despliegue: ONNX (opset 15, zipmap=False) en contenedor Docker (FastAPI + onnxruntime) detrás de Worker + Durable Object.</a:t>
             </a:r>
           </a:p>
         </p:txBody>
@@ -5180,7 +5170,7 @@
                   <a:srgbClr val="1A1A1A"/>
                 </a:solidFill>
               </a:rPr>
-              <a:t>Mejor modelo: xgb-d6-lr05-n500 con PR-AUC = 0.8819 y ROC-AUC = 0.9789 sobre el conjunto de prueba. Umbral óptimo de decisión: 0.9274, alcanzando F1 = 0.874, precisión = 0.941 y recall = 0.816 — equilibrio adecuado para un detector que se quiere conservador con los falsos positivos.</a:t>
+              <a:t>Mejor modelo — xgb-d6-lr05-n500: PR-AUC 0.8819, ROC-AUC 0.9789. Umbral 0.9274 ⇒ F1 0.874, precisión 0.941, recall 0.816.</a:t>
             </a:r>
           </a:p>
           <a:p>
@@ -5200,27 +5190,7 @@
                   <a:srgbClr val="1A1A1A"/>
                 </a:solidFill>
               </a:rPr>
-              <a:t>Dos corridas LightGBM (l31/l63 con balanceo agresivo) colapsaron a PR-AUC ≈ 0.03, mostrando lo fácil que es romper modelos sobre datos desbalanceados — las dejamos visibles como advertencia.</a:t>
-            </a:r>
-          </a:p>
-          <a:p>
-            <a:r>
-              <a:rPr sz="1800" b="0">
-                <a:solidFill>
-                  <a:srgbClr val="1A1A1A"/>
-                </a:solidFill>
-              </a:rPr>
-              <a:t/>
-            </a:r>
-          </a:p>
-          <a:p>
-            <a:r>
-              <a:rPr sz="1800" b="0">
-                <a:solidFill>
-                  <a:srgbClr val="1A1A1A"/>
-                </a:solidFill>
-              </a:rPr>
-              <a:t>Inferencia en producción: el endpoint POST /predict del contenedor desplegado en Cloudflare devuelve probabilidades que coinciden con el modelo sklearn original en 100/100 filas de prueba dentro de 1×10⁻⁴, con latencia mediana de 253 ms (p95 = 613 ms) desde un cliente residencial.</a:t>
+              <a:t>Inferencia en vivo: el endpoint en Cloudflare coincide con sklearn en 100/100 filas dentro de 1×10⁻⁴, latencia mediana 253 ms (p95 613 ms).</a:t>
             </a:r>
           </a:p>
         </p:txBody>
@@ -5998,7 +5968,7 @@
                   <a:srgbClr val="1A1A1A"/>
                 </a:solidFill>
               </a:rPr>
-              <a:t>El fraude con tarjeta de crédito ocurre en menos del 0.2% de las transacciones, lo que vuelve el problema severamente desbalanceado y exige métricas centradas en la clase positiva (PR-AUC en lugar de accuracy). Trabajamos con el conjunto público de la ULB (OpenML 1597, ~284 807 transacciones, 29 atributos numéricos), y atacamos el problema con un pipeline MLOps reproducible.</a:t>
+              <a:t>El fraude con tarjeta de crédito ocurre en menos del 0.2% de las transacciones (OpenML 1597, ULB, ~284 807 transacciones, 29 atributos numéricos): un problema severamente desbalanceado que exige métricas centradas en la clase positiva, en particular PR-AUC.</a:t>
             </a:r>
           </a:p>
           <a:p>
@@ -6018,7 +5988,7 @@
                   <a:srgbClr val="1A1A1A"/>
                 </a:solidFill>
               </a:rPr>
-              <a:t>Originalmente el proyecto pretendía desplegar en AWS, pero la cuenta académica de uno de los autores fue suspendida sin previo aviso. Reorientamos toda la infraestructura a Cloudflare (R2 como object store, Workers + Containers para inferencia). Esta narrativa de portabilidad — entrenar en Python, exportar a ONNX, servir como contenedor en el edge — es justamente lo que MLOps promete.</a:t>
+              <a:t>El pivote de AWS a Cloudflare fue forzado por la suspensión de una cuenta académica, pero refuerza el mensaje MLOps: entrenar en Python, exportar a ONNX, servir como contenedor en el edge.</a:t>
             </a:r>
           </a:p>
         </p:txBody>
@@ -7677,8 +7647,8 @@
         </p:blipFill>
         <p:spPr>
           <a:xfrm>
-            <a:off x="12527280" y="19202400"/>
-            <a:ext cx="17830800" cy="6864573"/>
+            <a:off x="12801600" y="20574000"/>
+            <a:ext cx="17099280" cy="6582950"/>
           </a:xfrm>
           <a:prstGeom prst="rect">
             <a:avLst/>
@@ -7701,7 +7671,7 @@
         </p:blipFill>
         <p:spPr>
           <a:xfrm>
-            <a:off x="12710160" y="30175200"/>
+            <a:off x="12984480" y="31089600"/>
             <a:ext cx="8229600" cy="3597899"/>
           </a:xfrm>
           <a:prstGeom prst="rect">
@@ -7725,7 +7695,7 @@
         </p:blipFill>
         <p:spPr>
           <a:xfrm>
-            <a:off x="21488400" y="30175200"/>
+            <a:off x="21762720" y="31089600"/>
             <a:ext cx="8229600" cy="6179810"/>
           </a:xfrm>
           <a:prstGeom prst="rect">
@@ -7749,8 +7719,8 @@
         </p:blipFill>
         <p:spPr>
           <a:xfrm>
-            <a:off x="2377440" y="17739360"/>
-            <a:ext cx="8869680" cy="5701937"/>
+            <a:off x="2560320" y="17922240"/>
+            <a:ext cx="8686800" cy="5584371"/>
           </a:xfrm>
           <a:prstGeom prst="rect">
             <a:avLst/>
@@ -7773,8 +7743,8 @@
         </p:blipFill>
         <p:spPr>
           <a:xfrm>
-            <a:off x="2926080" y="31089600"/>
-            <a:ext cx="7772400" cy="8511221"/>
+            <a:off x="3200400" y="30632400"/>
+            <a:ext cx="7040880" cy="7710165"/>
           </a:xfrm>
           <a:prstGeom prst="rect">
             <a:avLst/>

</xml_diff>